<commit_message>
Deck: re-export PDF/PPTX and refresh slide screenshots (3 slides)
</commit_message>
<xml_diff>
--- a/deck/export/pitch-deck.pptx
+++ b/deck/export/pitch-deck.pptx
@@ -8,11 +8,9 @@
     <p:sldId id="256" r:id="rId2"/>
     <p:sldId id="257" r:id="rId3"/>
     <p:sldId id="258" r:id="rId4"/>
-    <p:sldId id="259" r:id="rId5"/>
-    <p:sldId id="260" r:id="rId6"/>
   </p:sldIdLst>
   <p:notesMasterIdLst>
-    <p:notesMasterId r:id="rId7"/>
+    <p:notesMasterId r:id="rId5"/>
   </p:notesMasterIdLst>
   <p:sldSz cx="9334500" cy="5248275"/>
   <p:notesSz cx="5248275" cy="9334500"/>
@@ -506,10 +504,10 @@
           <a:p>
             <a:r>
               <a:rPr lang="en-US" dirty="0"/>
-              <a:t>[0:00–0:20] (~20 s)
-- Investigators review a huge number of alerts every day.
-- Most come from fixed rules: they fire often, but don't say why, or whether it's unusual for that person.
-- We built a tool that ranks players by risk and explains every flag.
+              <a:t>[0:00–0:30] (~30 s)
+- We're Bytes of the Round Table.
+- Investigators review a huge number of alerts every day. Most come from fixed rules: they fire often, but don't say why, or whether it's unusual for that person.
+- Our tool looks for laundering patterns like the linked ring in the lens: accounts sharing a device, card or address and moving money between them.
 - Everything you'll see runs on synthetic data we generated. No real player data.</a:t>
             </a:r>
             <a:endParaRPr lang="en-US" dirty="0"/>
@@ -598,13 +596,14 @@
           <a:p>
             <a:r>
               <a:rPr lang="en-US" dirty="0"/>
-              <a:t>[0:20–0:50] (~30 s)
-- Activity in: bets, deposits, devices, locations (all synthetic).
-- Context: every flag compares the player with their own 90-day history AND with peers (same age, income, region; and players who bet like them).
-- Detect: transparent rules, peer z-scores, Isolation Forest, and a gradient-boosting model whose SHAP drivers become one more reason.
-- Score out of 100: every point comes from a named reason with its numbers.
-- Output: one ranked queue across AML, Fraud and Safer Gambling. The investigator decides.
-Sources: README.md "How the score works"; docs/VALIDATION.md "AI model (supervised)".</a:t>
+              <a:t>[0:30–1:20] (~50 s)
+- Left, the pipeline: activity in (bets, deposits, devices, locations, all synthetic); context, so every flag compares the player with their own 90-day history and with peers; detection with transparent rules, peer z-scores, Isolation Forest and a gradient-boosting model whose SHAP drivers become one more reason.
+- The score is out of 100 and every point comes from a named reason with its numbers. Output: one ranked queue across AML, Fraud and Safer Gambling.
+- Right, a real screenshot of our dashboard on synthetic data, top alert opened.
+- 1: the score with a number, a label and a meter, never colour alone, plus a confidence rating and reasons it may be innocent.
+- 2: a case summary written only from computed evidence; any AI-written number is checked against the case file. It ends with a recommended next step.
+- The investigator decides (Accept, Escalate, Close as explained, Assign), recorded with their name. Also built: Evidence, Activity and Network tabs for linked accounts.
+Sources: README.md "Our Solution" and "How the score works"; docs/VALIDATION.md "AI model (supervised)".</a:t>
             </a:r>
             <a:endParaRPr lang="en-US" dirty="0"/>
           </a:p>
@@ -692,13 +691,15 @@
           <a:p>
             <a:r>
               <a:rPr lang="en-US" dirty="0"/>
-              <a:t>[0:50–1:20] (~30 s)
-- Real screenshots of our dashboard running locally on synthetic data (left: the queue; right: the top alert opened).
-- 1: one ranked queue across AML, Fraud and Safer Gambling. Every score shows a number, a label and a meter, never colour alone.
-- 2: the score with a confidence rating; the alert also lists reasons it may be innocent.
-- 3: a case summary written only from computed evidence; every number is checked against the case file. It ends with a recommended next step.
-- The investigator decides: Accept, Escalate, Close as explained or Assign, recorded with their name in an audit trail.
-- Also built (not shown): Evidence, Activity and Network tabs (linked accounts sharing a device, card or address).</a:t>
+              <a:t>[1:20–2:00] (~40 s)
+- 296 alerts from 5,000 synthetic players.
+- Only 0.40% of normal players get alerted; fixed-threshold rules flag 2.76%.
+- Ranking: the top 25, 50 and 100 alerts are all real planted cases; rules alone get 92%, 96%, 98%.
+- Honest caveat: our team built both the data and the detectors, so this shows the pipeline works, not real-world accuracy.
+- Next: real Jube case management (today only a mock of its API) and a CBN Crash Game feed (the data contract is a draft).
+- Responsible by design: synthetic data only; the investigator decides and can override with a reason; no score without its reasons.
+- Thank you. Questions?
+Source for every number: docs/VALIDATION.md ("Dataset", "Prioritisation: precision@k", "False positives"). See deck/SOURCES.md.</a:t>
             </a:r>
             <a:endParaRPr lang="en-US" dirty="0"/>
           </a:p>
@@ -722,190 +723,6 @@
             <a:fld id="{F7021451-1387-4CA6-816F-3879F97B5CBC}" type="slidenum">
               <a:rPr lang="en-US"/>
               <a:t>3</a:t>
-            </a:fld>
-            <a:endParaRPr lang="en-US"/>
-          </a:p>
-        </p:txBody>
-      </p:sp>
-    </p:spTree>
-    <p:extLst>
-      <p:ext uri="{BB962C8B-B14F-4D97-AF65-F5344CB8AC3E}">
-        <p14:creationId xmlns:p14="http://schemas.microsoft.com/office/powerpoint/2010/main" val="1024086991"/>
-      </p:ext>
-    </p:extLst>
-  </p:cSld>
-  <p:clrMapOvr>
-    <a:masterClrMapping/>
-  </p:clrMapOvr>
-</p:notes>
-</file>
-
-<file path=ppt/notesSlides/notesSlide4.xml><?xml version="1.0" encoding="utf-8"?>
-<p:notes xmlns:a="http://schemas.openxmlformats.org/drawingml/2006/main" xmlns:r="http://schemas.openxmlformats.org/officeDocument/2006/relationships" xmlns:p="http://schemas.openxmlformats.org/presentationml/2006/main">
-  <p:cSld>
-    <p:spTree>
-      <p:nvGrpSpPr>
-        <p:cNvPr id="1" name=""/>
-        <p:cNvGrpSpPr/>
-        <p:nvPr/>
-      </p:nvGrpSpPr>
-      <p:grpSpPr>
-        <a:xfrm>
-          <a:off x="0" y="0"/>
-          <a:ext cx="0" cy="0"/>
-          <a:chOff x="0" y="0"/>
-          <a:chExt cx="0" cy="0"/>
-        </a:xfrm>
-      </p:grpSpPr>
-      <p:sp>
-        <p:nvSpPr>
-          <p:cNvPr id="2" name="Slide Image Placeholder 1"/>
-          <p:cNvSpPr>
-            <a:spLocks noGrp="1" noRot="1" noChangeAspect="1"/>
-          </p:cNvSpPr>
-          <p:nvPr>
-            <p:ph type="sldImg"/>
-          </p:nvPr>
-        </p:nvSpPr>
-        <p:spPr/>
-      </p:sp>
-      <p:sp>
-        <p:nvSpPr>
-          <p:cNvPr id="3" name="Notes Placeholder 2"/>
-          <p:cNvSpPr>
-            <a:spLocks noGrp="1"/>
-          </p:cNvSpPr>
-          <p:nvPr>
-            <p:ph type="body" idx="1"/>
-          </p:nvPr>
-        </p:nvSpPr>
-        <p:spPr/>
-        <p:txBody>
-          <a:bodyPr/>
-          <a:lstStyle/>
-          <a:p>
-            <a:r>
-              <a:rPr lang="en-US" dirty="0"/>
-              <a:t>[1:20–1:45] (~25 s)
-- 296 alerts from 5,000 synthetic players.
-- Only 0.40% of normal players get alerted; fixed-threshold rules flag 2.76%.
-- Ranking: the top 25, 50 and 100 alerts are all real planted cases; rules alone get 92%, 96%, 98%.
-- Honest caveat: same team built the data and the detectors.
-Source for every number: docs/VALIDATION.md ("Dataset", "Prioritisation: precision@k", "False positives"). See deck/SOURCES.md.</a:t>
-            </a:r>
-            <a:endParaRPr lang="en-US" dirty="0"/>
-          </a:p>
-        </p:txBody>
-      </p:sp>
-      <p:sp>
-        <p:nvSpPr>
-          <p:cNvPr id="4" name="Slide Number Placeholder 3"/>
-          <p:cNvSpPr>
-            <a:spLocks noGrp="1"/>
-          </p:cNvSpPr>
-          <p:nvPr>
-            <p:ph type="sldNum" sz="quarter" idx="10"/>
-          </p:nvPr>
-        </p:nvSpPr>
-        <p:spPr/>
-        <p:txBody>
-          <a:bodyPr/>
-          <a:lstStyle/>
-          <a:p>
-            <a:fld id="{F7021451-1387-4CA6-816F-3879F97B5CBC}" type="slidenum">
-              <a:rPr lang="en-US"/>
-              <a:t>4</a:t>
-            </a:fld>
-            <a:endParaRPr lang="en-US"/>
-          </a:p>
-        </p:txBody>
-      </p:sp>
-    </p:spTree>
-    <p:extLst>
-      <p:ext uri="{BB962C8B-B14F-4D97-AF65-F5344CB8AC3E}">
-        <p14:creationId xmlns:p14="http://schemas.microsoft.com/office/powerpoint/2010/main" val="1024086991"/>
-      </p:ext>
-    </p:extLst>
-  </p:cSld>
-  <p:clrMapOvr>
-    <a:masterClrMapping/>
-  </p:clrMapOvr>
-</p:notes>
-</file>
-
-<file path=ppt/notesSlides/notesSlide5.xml><?xml version="1.0" encoding="utf-8"?>
-<p:notes xmlns:a="http://schemas.openxmlformats.org/drawingml/2006/main" xmlns:r="http://schemas.openxmlformats.org/officeDocument/2006/relationships" xmlns:p="http://schemas.openxmlformats.org/presentationml/2006/main">
-  <p:cSld>
-    <p:spTree>
-      <p:nvGrpSpPr>
-        <p:cNvPr id="1" name=""/>
-        <p:cNvGrpSpPr/>
-        <p:nvPr/>
-      </p:nvGrpSpPr>
-      <p:grpSpPr>
-        <a:xfrm>
-          <a:off x="0" y="0"/>
-          <a:ext cx="0" cy="0"/>
-          <a:chOff x="0" y="0"/>
-          <a:chExt cx="0" cy="0"/>
-        </a:xfrm>
-      </p:grpSpPr>
-      <p:sp>
-        <p:nvSpPr>
-          <p:cNvPr id="2" name="Slide Image Placeholder 1"/>
-          <p:cNvSpPr>
-            <a:spLocks noGrp="1" noRot="1" noChangeAspect="1"/>
-          </p:cNvSpPr>
-          <p:nvPr>
-            <p:ph type="sldImg"/>
-          </p:nvPr>
-        </p:nvSpPr>
-        <p:spPr/>
-      </p:sp>
-      <p:sp>
-        <p:nvSpPr>
-          <p:cNvPr id="3" name="Notes Placeholder 2"/>
-          <p:cNvSpPr>
-            <a:spLocks noGrp="1"/>
-          </p:cNvSpPr>
-          <p:nvPr>
-            <p:ph type="body" idx="1"/>
-          </p:nvPr>
-        </p:nvSpPr>
-        <p:spPr/>
-        <p:txBody>
-          <a:bodyPr/>
-          <a:lstStyle/>
-          <a:p>
-            <a:r>
-              <a:rPr lang="en-US" dirty="0"/>
-              <a:t>[1:45–2:00] (~15 s)
-- Roadmap: real Jube case management (today we only have a mock of its API), and a CBN Crash Game feed (data contract is a draft).
-- Responsible by design: synthetic data only; the tool recommends, the investigator decides and can override with a reason; no score without its reasons.
-- Thank you. Questions?</a:t>
-            </a:r>
-            <a:endParaRPr lang="en-US" dirty="0"/>
-          </a:p>
-        </p:txBody>
-      </p:sp>
-      <p:sp>
-        <p:nvSpPr>
-          <p:cNvPr id="4" name="Slide Number Placeholder 3"/>
-          <p:cNvSpPr>
-            <a:spLocks noGrp="1"/>
-          </p:cNvSpPr>
-          <p:nvPr>
-            <p:ph type="sldNum" sz="quarter" idx="10"/>
-          </p:nvPr>
-        </p:nvSpPr>
-        <p:spPr/>
-        <p:txBody>
-          <a:bodyPr/>
-          <a:lstStyle/>
-          <a:p>
-            <a:fld id="{F7021451-1387-4CA6-816F-3879F97B5CBC}" type="slidenum">
-              <a:rPr lang="en-US"/>
-              <a:t>5</a:t>
             </a:fld>
             <a:endParaRPr lang="en-US"/>
           </a:p>
@@ -1312,84 +1129,6 @@
 <file path=ppt/slides/slide3.xml><?xml version="1.0" encoding="utf-8"?>
 <p:sld xmlns:a="http://schemas.openxmlformats.org/drawingml/2006/main" xmlns:r="http://schemas.openxmlformats.org/officeDocument/2006/relationships" xmlns:p="http://schemas.openxmlformats.org/presentationml/2006/main">
   <p:cSld name="Slide 3">
-    <p:bg>
-      <p:bgPr>
-        <a:blipFill dpi="0" rotWithShape="1">
-          <a:blip r:embed="rId1">
-            <a:lum/>
-          </a:blip>
-          <a:srcRect/>
-          <a:stretch>
-            <a:fillRect/>
-          </a:stretch>
-        </a:blipFill>
-        <a:effectLst/>
-      </p:bgPr>
-    </p:bg>
-    <p:spTree>
-      <p:nvGrpSpPr>
-        <p:cNvPr id="1" name=""/>
-        <p:cNvGrpSpPr/>
-        <p:nvPr/>
-      </p:nvGrpSpPr>
-      <p:grpSpPr>
-        <a:xfrm>
-          <a:off x="0" y="0"/>
-          <a:ext cx="0" cy="0"/>
-          <a:chOff x="0" y="0"/>
-          <a:chExt cx="0" cy="0"/>
-        </a:xfrm>
-      </p:grpSpPr>
-    </p:spTree>
-  </p:cSld>
-  <p:clrMapOvr>
-    <a:masterClrMapping/>
-  </p:clrMapOvr>
-</p:sld>
-</file>
-
-<file path=ppt/slides/slide4.xml><?xml version="1.0" encoding="utf-8"?>
-<p:sld xmlns:a="http://schemas.openxmlformats.org/drawingml/2006/main" xmlns:r="http://schemas.openxmlformats.org/officeDocument/2006/relationships" xmlns:p="http://schemas.openxmlformats.org/presentationml/2006/main">
-  <p:cSld name="Slide 4">
-    <p:bg>
-      <p:bgPr>
-        <a:blipFill dpi="0" rotWithShape="1">
-          <a:blip r:embed="rId1">
-            <a:lum/>
-          </a:blip>
-          <a:srcRect/>
-          <a:stretch>
-            <a:fillRect/>
-          </a:stretch>
-        </a:blipFill>
-        <a:effectLst/>
-      </p:bgPr>
-    </p:bg>
-    <p:spTree>
-      <p:nvGrpSpPr>
-        <p:cNvPr id="1" name=""/>
-        <p:cNvGrpSpPr/>
-        <p:nvPr/>
-      </p:nvGrpSpPr>
-      <p:grpSpPr>
-        <a:xfrm>
-          <a:off x="0" y="0"/>
-          <a:ext cx="0" cy="0"/>
-          <a:chOff x="0" y="0"/>
-          <a:chExt cx="0" cy="0"/>
-        </a:xfrm>
-      </p:grpSpPr>
-    </p:spTree>
-  </p:cSld>
-  <p:clrMapOvr>
-    <a:masterClrMapping/>
-  </p:clrMapOvr>
-</p:sld>
-</file>
-
-<file path=ppt/slides/slide5.xml><?xml version="1.0" encoding="utf-8"?>
-<p:sld xmlns:a="http://schemas.openxmlformats.org/drawingml/2006/main" xmlns:r="http://schemas.openxmlformats.org/officeDocument/2006/relationships" xmlns:p="http://schemas.openxmlformats.org/presentationml/2006/main">
-  <p:cSld name="Slide 5">
     <p:bg>
       <p:bgPr>
         <a:blipFill dpi="0" rotWithShape="1">

</xml_diff>